<commit_message>
Update team role and faculty mentor
</commit_message>
<xml_diff>
--- a/docs/presentation/GlucoTwin_Presentation.pptx
+++ b/docs/presentation/GlucoTwin_Presentation.pptx
@@ -3708,7 +3708,7 @@
               </a:defRPr>
             </a:pPr>
             <a:r>
-              <a:t>•  Team GlucoTwin_RIMT-University · Nikhil Chawla, Full-Stack AI &amp; Digital Health Lead · BCA – AI &amp; Data Science, RIMT University.</a:t>
+              <a:t>•  Team GlucoTwin_RIMT-University · Nikhil Chawla, AI Engineer · BCA – AI &amp; Data Science, RIMT University.</a:t>
             </a:r>
           </a:p>
           <a:p>
@@ -5690,7 +5690,7 @@
               </a:defRPr>
             </a:pPr>
             <a:r>
-              <a:t>•  Team GlucoTwin_RIMT-University. Nikhil Chawla, team leader — Full-Stack AI &amp; Digital Health Lead, BCA – AI &amp; Data Science, RIMT University, Mandi Gobindgarh, Punjab. Faculty mentor: Dr. Ashish Oberoi (Dean / Faculty Mentor, Department of Computer Applications, RIMT University).</a:t>
+              <a:t>•  Team GlucoTwin_RIMT-University. Nikhil Chawla, team leader — AI Engineer, BCA – AI &amp; Data Science, RIMT University, Mandi Gobindgarh, Punjab. Faculty mentor: Dr. Rajkumar (Head of Department, Computer Applications, RIMT University).</a:t>
             </a:r>
           </a:p>
           <a:p>

</xml_diff>